<commit_message>
Ignore Claude outputs folder; remove leftover template note from research canvas
Co-Authored-By: Claude Opus 5.5 <noreply@anthropic.com>
Claude-Session: https://claude.ai/code/session_015n7vr7wEB5bV9xQyBezfAS
</commit_message>
<xml_diff>
--- a/Notes/Research_Canvas_McKinley.pptx
+++ b/Notes/Research_Canvas_McKinley.pptx
@@ -565,49 +565,7 @@
         <p:txBody>
           <a:bodyPr/>
           <a:lstStyle/>
-          <a:p>
-            <a:pPr marL="228600" indent="0">
-              <a:buFontTx/>
-              <a:buNone/>
-            </a:pPr>
-            <a:r>
-              <a:rPr lang="en-US" sz="800" kern="1200" dirty="0">
-                <a:solidFill>
-                  <a:schemeClr val="tx1"/>
-                </a:solidFill>
-                <a:latin typeface="+mj-lt"/>
-                <a:ea typeface="+mn-ea"/>
-                <a:cs typeface="+mn-cs"/>
-              </a:rPr>
-              <a:t>Possible data : </a:t>
-            </a:r>
-            <a:r>
-              <a:rPr lang="en-US" sz="1050" dirty="0"/>
-              <a:t>number of tweets by sentiment polarity and location (June 2011–April 2019</a:t>
-            </a:r>
-            <a:endParaRPr lang="en-US" sz="800" kern="1200" dirty="0">
-              <a:solidFill>
-                <a:schemeClr val="tx1"/>
-              </a:solidFill>
-              <a:latin typeface="+mj-lt"/>
-              <a:ea typeface="+mn-ea"/>
-              <a:cs typeface="+mn-cs"/>
-            </a:endParaRPr>
-          </a:p>
-          <a:p>
-            <a:pPr marL="228600" indent="0">
-              <a:buFontTx/>
-              <a:buNone/>
-            </a:pPr>
-            <a:endParaRPr lang="en-US" sz="800" kern="1200" dirty="0">
-              <a:solidFill>
-                <a:schemeClr val="tx1"/>
-              </a:solidFill>
-              <a:latin typeface="+mj-lt"/>
-              <a:ea typeface="+mn-ea"/>
-              <a:cs typeface="+mn-cs"/>
-            </a:endParaRPr>
-          </a:p>
+          <a:p/>
         </p:txBody>
       </p:sp>
       <p:sp>

</xml_diff>